<commit_message>
added more meeting slides
</commit_message>
<xml_diff>
--- a/2025/specification-education-monthly/2025-11-Europe-Asia.pptx
+++ b/2025/specification-education-monthly/2025-11-Europe-Asia.pptx
@@ -6546,7 +6546,7 @@
             </a:pPr>
             <a:r>
               <a:rPr lang="en-US" dirty="0"/>
-              <a:t>Limited responses but wide geographic coverage. Interestingly, most responders are not yet adaptors, indicating they are in examination phase:</a:t>
+              <a:t>Limited responses (7) but wide geographic coverage. Interestingly, most responders are not yet adaptors, indicating they are in examination phase:</a:t>
             </a:r>
           </a:p>
         </p:txBody>
@@ -6758,7 +6758,7 @@
         <p:spPr>
           <a:xfrm>
             <a:off x="180087" y="1017800"/>
-            <a:ext cx="3659392" cy="2123438"/>
+            <a:ext cx="3659391" cy="2123438"/>
           </a:xfrm>
           <a:prstGeom prst="rect">
             <a:avLst/>

</xml_diff>